<commit_message>
Simplify architecture diagram and demo deck
</commit_message>
<xml_diff>
--- a/docs/tdc-oci-ai-agents-demo-oracle.pptx
+++ b/docs/tdc-oci-ai-agents-demo-oracle.pptx
@@ -8,11 +8,7 @@
     <p:notesMasterId xmlns:r="http://schemas.openxmlformats.org/officeDocument/2006/relationships" r:id="R6c08d62262f0495a"/>
   </p:notesMasterIdLst>
   <p:sldIdLst>
-    <p:sldId xmlns:r="http://schemas.openxmlformats.org/officeDocument/2006/relationships" id="256" r:id="R38ebcc432e614e2a"/>
     <p:sldId xmlns:r="http://schemas.openxmlformats.org/officeDocument/2006/relationships" id="257" r:id="Rb75d3626832e4efe"/>
-    <p:sldId xmlns:r="http://schemas.openxmlformats.org/officeDocument/2006/relationships" id="258" r:id="R06ceb22789c048a7"/>
-    <p:sldId xmlns:r="http://schemas.openxmlformats.org/officeDocument/2006/relationships" id="259" r:id="R91a110b73b1e46a7"/>
-    <p:sldId xmlns:r="http://schemas.openxmlformats.org/officeDocument/2006/relationships" id="264" r:id="R09c0a37e4bf044b3"/>
   </p:sldIdLst>
   <p:sldSz cx="12192000" cy="6858000"/>
   <p:notesSz cx="6858000" cy="9144000"/>
@@ -405,271 +401,7 @@
 </a:theme>
 </file>
 
-<file path=ppt/notesSlides/notesSlide1.xml><?xml version="1.0" encoding="utf-8"?>
-<p:notes xmlns:p="http://schemas.openxmlformats.org/presentationml/2006/main">
-  <p:cSld>
-    <p:spTree>
-      <p:nvGrpSpPr>
-        <p:cNvPr id="1" name=""/>
-        <p:cNvGrpSpPr/>
-        <p:nvPr/>
-      </p:nvGrpSpPr>
-      <p:grpSpPr>
-        <a:xfrm xmlns:a="http://schemas.openxmlformats.org/drawingml/2006/main"/>
-      </p:grpSpPr>
-      <p:sp>
-        <p:nvSpPr>
-          <p:cNvPr id="2" name="Slide Image Placeholder 1"/>
-          <p:cNvSpPr>
-            <a:spLocks xmlns:a="http://schemas.openxmlformats.org/drawingml/2006/main" noGrp="1"/>
-          </p:cNvSpPr>
-          <p:nvPr>
-            <p:ph type="sldImg" idx="0"/>
-          </p:nvPr>
-        </p:nvSpPr>
-        <p:spPr/>
-      </p:sp>
-      <p:sp>
-        <p:nvSpPr>
-          <p:cNvPr id="3" name="Notes Placeholder 2"/>
-          <p:cNvSpPr>
-            <a:spLocks xmlns:a="http://schemas.openxmlformats.org/drawingml/2006/main" noGrp="1"/>
-          </p:cNvSpPr>
-          <p:nvPr>
-            <p:ph type="body" idx="1"/>
-          </p:nvPr>
-        </p:nvSpPr>
-        <p:spPr/>
-        <p:txBody>
-          <a:bodyPr xmlns:a="http://schemas.openxmlformats.org/drawingml/2006/main"/>
-          <a:lstStyle xmlns:a="http://schemas.openxmlformats.org/drawingml/2006/main"/>
-          <a:p xmlns:a="http://schemas.openxmlformats.org/drawingml/2006/main"/>
-        </p:txBody>
-      </p:sp>
-      <p:sp>
-        <p:nvSpPr>
-          <p:cNvPr id="4" name="Slide Number Placeholder 3"/>
-          <p:cNvSpPr>
-            <a:spLocks xmlns:a="http://schemas.openxmlformats.org/drawingml/2006/main" noGrp="1"/>
-          </p:cNvSpPr>
-          <p:nvPr>
-            <p:ph type="sldNum" idx="5"/>
-          </p:nvPr>
-        </p:nvSpPr>
-        <p:spPr/>
-        <p:txBody>
-          <a:bodyPr xmlns:a="http://schemas.openxmlformats.org/drawingml/2006/main"/>
-          <a:lstStyle xmlns:a="http://schemas.openxmlformats.org/drawingml/2006/main"/>
-          <a:p xmlns:a="http://schemas.openxmlformats.org/drawingml/2006/main"/>
-        </p:txBody>
-      </p:sp>
-    </p:spTree>
-  </p:cSld>
-  <p:clrMapOvr>
-    <a:masterClrMapping xmlns:a="http://schemas.openxmlformats.org/drawingml/2006/main"/>
-  </p:clrMapOvr>
-</p:notes>
-</file>
-
 <file path=ppt/notesSlides/notesSlide2.xml><?xml version="1.0" encoding="utf-8"?>
-<p:notes xmlns:p="http://schemas.openxmlformats.org/presentationml/2006/main">
-  <p:cSld>
-    <p:spTree>
-      <p:nvGrpSpPr>
-        <p:cNvPr id="1" name=""/>
-        <p:cNvGrpSpPr/>
-        <p:nvPr/>
-      </p:nvGrpSpPr>
-      <p:grpSpPr>
-        <a:xfrm xmlns:a="http://schemas.openxmlformats.org/drawingml/2006/main"/>
-      </p:grpSpPr>
-      <p:sp>
-        <p:nvSpPr>
-          <p:cNvPr id="2" name="Slide Image Placeholder 1"/>
-          <p:cNvSpPr>
-            <a:spLocks xmlns:a="http://schemas.openxmlformats.org/drawingml/2006/main" noGrp="1"/>
-          </p:cNvSpPr>
-          <p:nvPr>
-            <p:ph type="sldImg" idx="0"/>
-          </p:nvPr>
-        </p:nvSpPr>
-        <p:spPr/>
-      </p:sp>
-      <p:sp>
-        <p:nvSpPr>
-          <p:cNvPr id="3" name="Notes Placeholder 2"/>
-          <p:cNvSpPr>
-            <a:spLocks xmlns:a="http://schemas.openxmlformats.org/drawingml/2006/main" noGrp="1"/>
-          </p:cNvSpPr>
-          <p:nvPr>
-            <p:ph type="body" idx="1"/>
-          </p:nvPr>
-        </p:nvSpPr>
-        <p:spPr/>
-        <p:txBody>
-          <a:bodyPr xmlns:a="http://schemas.openxmlformats.org/drawingml/2006/main"/>
-          <a:lstStyle xmlns:a="http://schemas.openxmlformats.org/drawingml/2006/main"/>
-          <a:p xmlns:a="http://schemas.openxmlformats.org/drawingml/2006/main"/>
-        </p:txBody>
-      </p:sp>
-      <p:sp>
-        <p:nvSpPr>
-          <p:cNvPr id="4" name="Slide Number Placeholder 3"/>
-          <p:cNvSpPr>
-            <a:spLocks xmlns:a="http://schemas.openxmlformats.org/drawingml/2006/main" noGrp="1"/>
-          </p:cNvSpPr>
-          <p:nvPr>
-            <p:ph type="sldNum" idx="5"/>
-          </p:nvPr>
-        </p:nvSpPr>
-        <p:spPr/>
-        <p:txBody>
-          <a:bodyPr xmlns:a="http://schemas.openxmlformats.org/drawingml/2006/main"/>
-          <a:lstStyle xmlns:a="http://schemas.openxmlformats.org/drawingml/2006/main"/>
-          <a:p xmlns:a="http://schemas.openxmlformats.org/drawingml/2006/main"/>
-        </p:txBody>
-      </p:sp>
-    </p:spTree>
-  </p:cSld>
-  <p:clrMapOvr>
-    <a:masterClrMapping xmlns:a="http://schemas.openxmlformats.org/drawingml/2006/main"/>
-  </p:clrMapOvr>
-</p:notes>
-</file>
-
-<file path=ppt/notesSlides/notesSlide3.xml><?xml version="1.0" encoding="utf-8"?>
-<p:notes xmlns:p="http://schemas.openxmlformats.org/presentationml/2006/main">
-  <p:cSld>
-    <p:spTree>
-      <p:nvGrpSpPr>
-        <p:cNvPr id="1" name=""/>
-        <p:cNvGrpSpPr/>
-        <p:nvPr/>
-      </p:nvGrpSpPr>
-      <p:grpSpPr>
-        <a:xfrm xmlns:a="http://schemas.openxmlformats.org/drawingml/2006/main"/>
-      </p:grpSpPr>
-      <p:sp>
-        <p:nvSpPr>
-          <p:cNvPr id="2" name="Slide Image Placeholder 1"/>
-          <p:cNvSpPr>
-            <a:spLocks xmlns:a="http://schemas.openxmlformats.org/drawingml/2006/main" noGrp="1"/>
-          </p:cNvSpPr>
-          <p:nvPr>
-            <p:ph type="sldImg" idx="0"/>
-          </p:nvPr>
-        </p:nvSpPr>
-        <p:spPr/>
-      </p:sp>
-      <p:sp>
-        <p:nvSpPr>
-          <p:cNvPr id="3" name="Notes Placeholder 2"/>
-          <p:cNvSpPr>
-            <a:spLocks xmlns:a="http://schemas.openxmlformats.org/drawingml/2006/main" noGrp="1"/>
-          </p:cNvSpPr>
-          <p:nvPr>
-            <p:ph type="body" idx="1"/>
-          </p:nvPr>
-        </p:nvSpPr>
-        <p:spPr/>
-        <p:txBody>
-          <a:bodyPr xmlns:a="http://schemas.openxmlformats.org/drawingml/2006/main"/>
-          <a:lstStyle xmlns:a="http://schemas.openxmlformats.org/drawingml/2006/main"/>
-          <a:p xmlns:a="http://schemas.openxmlformats.org/drawingml/2006/main"/>
-        </p:txBody>
-      </p:sp>
-      <p:sp>
-        <p:nvSpPr>
-          <p:cNvPr id="4" name="Slide Number Placeholder 3"/>
-          <p:cNvSpPr>
-            <a:spLocks xmlns:a="http://schemas.openxmlformats.org/drawingml/2006/main" noGrp="1"/>
-          </p:cNvSpPr>
-          <p:nvPr>
-            <p:ph type="sldNum" idx="5"/>
-          </p:nvPr>
-        </p:nvSpPr>
-        <p:spPr/>
-        <p:txBody>
-          <a:bodyPr xmlns:a="http://schemas.openxmlformats.org/drawingml/2006/main"/>
-          <a:lstStyle xmlns:a="http://schemas.openxmlformats.org/drawingml/2006/main"/>
-          <a:p xmlns:a="http://schemas.openxmlformats.org/drawingml/2006/main"/>
-        </p:txBody>
-      </p:sp>
-    </p:spTree>
-  </p:cSld>
-  <p:clrMapOvr>
-    <a:masterClrMapping xmlns:a="http://schemas.openxmlformats.org/drawingml/2006/main"/>
-  </p:clrMapOvr>
-</p:notes>
-</file>
-
-<file path=ppt/notesSlides/notesSlide4.xml><?xml version="1.0" encoding="utf-8"?>
-<p:notes xmlns:p="http://schemas.openxmlformats.org/presentationml/2006/main">
-  <p:cSld>
-    <p:spTree>
-      <p:nvGrpSpPr>
-        <p:cNvPr id="1" name=""/>
-        <p:cNvGrpSpPr/>
-        <p:nvPr/>
-      </p:nvGrpSpPr>
-      <p:grpSpPr>
-        <a:xfrm xmlns:a="http://schemas.openxmlformats.org/drawingml/2006/main"/>
-      </p:grpSpPr>
-      <p:sp>
-        <p:nvSpPr>
-          <p:cNvPr id="2" name="Slide Image Placeholder 1"/>
-          <p:cNvSpPr>
-            <a:spLocks xmlns:a="http://schemas.openxmlformats.org/drawingml/2006/main" noGrp="1"/>
-          </p:cNvSpPr>
-          <p:nvPr>
-            <p:ph type="sldImg" idx="0"/>
-          </p:nvPr>
-        </p:nvSpPr>
-        <p:spPr/>
-      </p:sp>
-      <p:sp>
-        <p:nvSpPr>
-          <p:cNvPr id="3" name="Notes Placeholder 2"/>
-          <p:cNvSpPr>
-            <a:spLocks xmlns:a="http://schemas.openxmlformats.org/drawingml/2006/main" noGrp="1"/>
-          </p:cNvSpPr>
-          <p:nvPr>
-            <p:ph type="body" idx="1"/>
-          </p:nvPr>
-        </p:nvSpPr>
-        <p:spPr/>
-        <p:txBody>
-          <a:bodyPr xmlns:a="http://schemas.openxmlformats.org/drawingml/2006/main"/>
-          <a:lstStyle xmlns:a="http://schemas.openxmlformats.org/drawingml/2006/main"/>
-          <a:p xmlns:a="http://schemas.openxmlformats.org/drawingml/2006/main"/>
-        </p:txBody>
-      </p:sp>
-      <p:sp>
-        <p:nvSpPr>
-          <p:cNvPr id="4" name="Slide Number Placeholder 3"/>
-          <p:cNvSpPr>
-            <a:spLocks xmlns:a="http://schemas.openxmlformats.org/drawingml/2006/main" noGrp="1"/>
-          </p:cNvSpPr>
-          <p:nvPr>
-            <p:ph type="sldNum" idx="5"/>
-          </p:nvPr>
-        </p:nvSpPr>
-        <p:spPr/>
-        <p:txBody>
-          <a:bodyPr xmlns:a="http://schemas.openxmlformats.org/drawingml/2006/main"/>
-          <a:lstStyle xmlns:a="http://schemas.openxmlformats.org/drawingml/2006/main"/>
-          <a:p xmlns:a="http://schemas.openxmlformats.org/drawingml/2006/main"/>
-        </p:txBody>
-      </p:sp>
-    </p:spTree>
-  </p:cSld>
-  <p:clrMapOvr>
-    <a:masterClrMapping xmlns:a="http://schemas.openxmlformats.org/drawingml/2006/main"/>
-  </p:clrMapOvr>
-</p:notes>
-</file>
-
-<file path=ppt/notesSlides/notesSlide9.xml><?xml version="1.0" encoding="utf-8"?>
 <p:notes xmlns:p="http://schemas.openxmlformats.org/presentationml/2006/main">
   <p:cSld>
     <p:spTree>
@@ -50041,303 +49773,6 @@
 </a:theme>
 </file>
 
-<file path=ppt/slides/slide1.xml><?xml version="1.0" encoding="utf-8"?>
-<p:sld xmlns:p="http://schemas.openxmlformats.org/presentationml/2006/main">
-  <p:cSld>
-    <p:spTree>
-      <p:nvGrpSpPr>
-        <p:cNvPr id="1" name=""/>
-        <p:cNvGrpSpPr/>
-        <p:nvPr/>
-      </p:nvGrpSpPr>
-      <p:grpSpPr>
-        <a:xfrm xmlns:a="http://schemas.openxmlformats.org/drawingml/2006/main"/>
-      </p:grpSpPr>
-      <p:sp>
-        <p:nvSpPr>
-          <p:cNvPr id="6" name="Slide Number Placeholder 5">
-            <a:extLst xmlns:a="http://schemas.openxmlformats.org/drawingml/2006/main">
-              <a:ext uri="{FF2B5EF4-FFF2-40B4-BE49-F238E27FC236}">
-                <a16:creationId xmlns:a16="http://schemas.microsoft.com/office/drawing/2014/main" id="{EEAB4414-CB66-1961-4851-D15630C3CD26}"/>
-              </a:ext>
-            </a:extLst>
-          </p:cNvPr>
-          <p:cNvSpPr>
-            <a:spLocks xmlns:a="http://schemas.openxmlformats.org/drawingml/2006/main" noGrp="1"/>
-          </p:cNvSpPr>
-          <p:nvPr>
-            <p:ph type="sldNum" idx="12"/>
-          </p:nvPr>
-        </p:nvSpPr>
-        <p:spPr>
-          <a:xfrm xmlns:a="http://schemas.openxmlformats.org/drawingml/2006/main">
-            <a:off x="762000" y="6995117"/>
-            <a:ext cx="365760" cy="365760"/>
-          </a:xfrm>
-        </p:spPr>
-        <p:txBody>
-          <a:bodyPr xmlns:a="http://schemas.openxmlformats.org/drawingml/2006/main"/>
-          <a:lstStyle xmlns:a="http://schemas.openxmlformats.org/drawingml/2006/main"/>
-          <a:p xmlns:a="http://schemas.openxmlformats.org/drawingml/2006/main">
-            <a:r>
-              <a:rPr sz="600">
-                <a:solidFill>
-                  <a:srgbClr val="5C5650"/>
-                </a:solidFill>
-                <a:latin typeface="Oracle Sans"/>
-              </a:rPr>
-              <a:t>1</a:t>
-            </a:r>
-          </a:p>
-        </p:txBody>
-      </p:sp>
-      <p:sp>
-        <p:nvSpPr>
-          <p:cNvPr id="7" name="Footer Placeholder 6">
-            <a:extLst xmlns:a="http://schemas.openxmlformats.org/drawingml/2006/main">
-              <a:ext uri="{FF2B5EF4-FFF2-40B4-BE49-F238E27FC236}">
-                <a16:creationId xmlns:a16="http://schemas.microsoft.com/office/drawing/2014/main" id="{2F6DC71C-6266-BA3E-B5B9-4423AABAEE66}"/>
-              </a:ext>
-            </a:extLst>
-          </p:cNvPr>
-          <p:cNvSpPr>
-            <a:spLocks xmlns:a="http://schemas.openxmlformats.org/drawingml/2006/main" noGrp="1"/>
-          </p:cNvSpPr>
-          <p:nvPr>
-            <p:ph type="ftr" idx="36"/>
-          </p:nvPr>
-        </p:nvSpPr>
-        <p:spPr>
-          <a:xfrm xmlns:a="http://schemas.openxmlformats.org/drawingml/2006/main">
-            <a:off x="1127759" y="6995435"/>
-            <a:ext cx="5745379" cy="365125"/>
-          </a:xfrm>
-        </p:spPr>
-        <p:txBody>
-          <a:bodyPr xmlns:a="http://schemas.openxmlformats.org/drawingml/2006/main"/>
-          <a:lstStyle xmlns:a="http://schemas.openxmlformats.org/drawingml/2006/main"/>
-          <a:p xmlns:a="http://schemas.openxmlformats.org/drawingml/2006/main">
-            <a:r>
-              <a:rPr sz="600">
-                <a:solidFill>
-                  <a:srgbClr val="5C5650"/>
-                </a:solidFill>
-                <a:latin typeface="Oracle Sans"/>
-              </a:rPr>
-              <a:t>Copyright © 2026, Oracle and/or its affiliates | Confidential: Internal</a:t>
-            </a:r>
-          </a:p>
-        </p:txBody>
-      </p:sp>
-      <p:sp xmlns:a="http://schemas.openxmlformats.org/drawingml/2006/main">
-        <p:nvSpPr>
-          <p:cNvPr id="8" name="TextBox 7"/>
-          <p:cNvSpPr txBox="1"/>
-          <p:nvPr/>
-        </p:nvSpPr>
-        <p:spPr>
-          <a:xfrm>
-            <a:off x="685800" y="685800"/>
-            <a:ext cx="6766560" cy="594360"/>
-          </a:xfrm>
-          <a:prstGeom prst="rect">
-            <a:avLst/>
-          </a:prstGeom>
-          <a:noFill/>
-        </p:spPr>
-        <p:txBody>
-          <a:bodyPr wrap="square">
-            <a:spAutoFit/>
-          </a:bodyPr>
-          <a:lstStyle/>
-          <a:p>
-            <a:pPr algn="l"/>
-            <a:r>
-              <a:rPr sz="3400" b="1">
-                <a:solidFill>
-                  <a:srgbClr val="FFFFFF"/>
-                </a:solidFill>
-                <a:latin typeface="Oracle Sans"/>
-              </a:rPr>
-              <a:t>Lab TDC: AI Agents na OCI</a:t>
-            </a:r>
-          </a:p>
-        </p:txBody>
-      </p:sp>
-      <p:sp xmlns:a="http://schemas.openxmlformats.org/drawingml/2006/main">
-        <p:nvSpPr>
-          <p:cNvPr id="9" name="TextBox 8"/>
-          <p:cNvSpPr txBox="1"/>
-          <p:nvPr/>
-        </p:nvSpPr>
-        <p:spPr>
-          <a:xfrm>
-            <a:off x="713232" y="1298448"/>
-            <a:ext cx="7132320" cy="320040"/>
-          </a:xfrm>
-          <a:prstGeom prst="rect">
-            <a:avLst/>
-          </a:prstGeom>
-          <a:noFill/>
-        </p:spPr>
-        <p:txBody>
-          <a:bodyPr wrap="square">
-            <a:spAutoFit/>
-          </a:bodyPr>
-          <a:lstStyle/>
-          <a:p>
-            <a:pPr algn="l"/>
-            <a:r>
-              <a:rPr sz="1800" b="0">
-                <a:solidFill>
-                  <a:srgbClr val="FFFFFF"/>
-                </a:solidFill>
-                <a:latin typeface="Oracle Sans"/>
-              </a:rPr>
-              <a:t>RAG, Custom Tools e endpoint em uma demo de 1 hora</a:t>
-            </a:r>
-          </a:p>
-        </p:txBody>
-      </p:sp>
-      <p:sp xmlns:a="http://schemas.openxmlformats.org/drawingml/2006/main">
-        <p:nvSpPr>
-          <p:cNvPr id="10" name="TextBox 9"/>
-          <p:cNvSpPr txBox="1"/>
-          <p:nvPr/>
-        </p:nvSpPr>
-        <p:spPr>
-          <a:xfrm>
-            <a:off x="713232" y="4160520"/>
-            <a:ext cx="2286000" cy="274320"/>
-          </a:xfrm>
-          <a:prstGeom prst="rect">
-            <a:avLst/>
-          </a:prstGeom>
-          <a:noFill/>
-        </p:spPr>
-        <p:txBody>
-          <a:bodyPr wrap="square">
-            <a:spAutoFit/>
-          </a:bodyPr>
-          <a:lstStyle/>
-          <a:p>
-            <a:pPr algn="l"/>
-            <a:r>
-              <a:rPr sz="1400" b="0">
-                <a:solidFill>
-                  <a:srgbClr val="FFFFFF"/>
-                </a:solidFill>
-                <a:latin typeface="Oracle Sans"/>
-              </a:rPr>
-              <a:t>Material de apoio</a:t>
-            </a:r>
-          </a:p>
-        </p:txBody>
-      </p:sp>
-      <p:sp xmlns:a="http://schemas.openxmlformats.org/drawingml/2006/main">
-        <p:nvSpPr>
-          <p:cNvPr id="11" name="TextBox 10"/>
-          <p:cNvSpPr txBox="1"/>
-          <p:nvPr/>
-        </p:nvSpPr>
-        <p:spPr>
-          <a:xfrm>
-            <a:off x="713232" y="4480560"/>
-            <a:ext cx="5669280" cy="384048"/>
-          </a:xfrm>
-          <a:prstGeom prst="rect">
-            <a:avLst/>
-          </a:prstGeom>
-          <a:noFill/>
-        </p:spPr>
-        <p:txBody>
-          <a:bodyPr wrap="none">
-            <a:spAutoFit/>
-          </a:bodyPr>
-          <a:lstStyle/>
-          <a:p>
-            <a:r>
-              <a:rPr sz="1600">
-                <a:solidFill>
-                  <a:srgbClr val="2C5967"/>
-                </a:solidFill>
-                <a:latin typeface="Oracle Sans"/>
-                <a:hlinkClick xmlns:ns0="http://schemas.openxmlformats.org/officeDocument/2006/relationships" ns0:id="rId3"/>
-              </a:rPr>
-              <a:t>https://github.com/LiviaFernandes/tdc-oci-ai-agents-lab</a:t>
-            </a:r>
-          </a:p>
-        </p:txBody>
-      </p:sp>
-      <p:pic xmlns:a="http://schemas.openxmlformats.org/drawingml/2006/main" xmlns:r="http://schemas.openxmlformats.org/officeDocument/2006/relationships">
-        <p:nvPicPr>
-          <p:cNvPr id="12" name="Picture 11" descr="github-qr.png"/>
-          <p:cNvPicPr>
-            <a:picLocks noChangeAspect="1"/>
-          </p:cNvPicPr>
-          <p:nvPr/>
-        </p:nvPicPr>
-        <p:blipFill>
-          <a:blip r:embed="rId4"/>
-          <a:stretch>
-            <a:fillRect/>
-          </a:stretch>
-        </p:blipFill>
-        <p:spPr>
-          <a:xfrm>
-            <a:off x="9281160" y="1051560"/>
-            <a:ext cx="1874519" cy="1874519"/>
-          </a:xfrm>
-          <a:prstGeom prst="rect">
-            <a:avLst/>
-          </a:prstGeom>
-        </p:spPr>
-      </p:pic>
-      <p:sp xmlns:a="http://schemas.openxmlformats.org/drawingml/2006/main">
-        <p:nvSpPr>
-          <p:cNvPr id="13" name="TextBox 12"/>
-          <p:cNvSpPr txBox="1"/>
-          <p:nvPr/>
-        </p:nvSpPr>
-        <p:spPr>
-          <a:xfrm>
-            <a:off x="8823960" y="3063240"/>
-            <a:ext cx="2743200" cy="365760"/>
-          </a:xfrm>
-          <a:prstGeom prst="rect">
-            <a:avLst/>
-          </a:prstGeom>
-          <a:noFill/>
-        </p:spPr>
-        <p:txBody>
-          <a:bodyPr wrap="square">
-            <a:spAutoFit/>
-          </a:bodyPr>
-          <a:lstStyle/>
-          <a:p>
-            <a:pPr algn="ctr"/>
-            <a:r>
-              <a:rPr sz="1300" b="0">
-                <a:solidFill>
-                  <a:srgbClr val="FFFFFF"/>
-                </a:solidFill>
-                <a:latin typeface="Oracle Sans"/>
-              </a:rPr>
-              <a:t>Aponte a camera para abrir o GitHub</a:t>
-            </a:r>
-          </a:p>
-        </p:txBody>
-      </p:sp>
-    </p:spTree>
-    <p:extLst>
-      <p:ext uri="{BB962C8B-B14F-4D97-AF65-F5344CB8AC3E}">
-        <p14:creationId xmlns:p14="http://schemas.microsoft.com/office/powerpoint/2010/main" val="2008023158"/>
-      </p:ext>
-    </p:extLst>
-  </p:cSld>
-</p:sld>
-</file>
-
 <file path=ppt/slides/slide2.xml><?xml version="1.0" encoding="utf-8"?>
 <p:sld xmlns:p="http://schemas.openxmlformats.org/presentationml/2006/main">
   <p:cSld>
@@ -50390,7 +49825,7 @@
                 </a:solidFill>
                 <a:latin typeface="Oracle Sans"/>
               </a:rPr>
-              <a:t>2</a:t>
+              <a:t>1</a:t>
             </a:r>
           </a:p>
         </p:txBody>
@@ -50441,8 +49876,8 @@
         </p:nvSpPr>
         <p:spPr>
           <a:xfrm>
-            <a:off x="640080" y="502920"/>
-            <a:ext cx="6126480" cy="457200"/>
+            <a:off x="502920" y="320040"/>
+            <a:ext cx="5943600" cy="411480"/>
           </a:xfrm>
           <a:prstGeom prst="rect">
             <a:avLst/>
@@ -50457,13 +49892,13 @@
           <a:p>
             <a:pPr algn="l"/>
             <a:r>
-              <a:rPr sz="3000" b="1">
+              <a:rPr sz="2700" b="1">
                 <a:solidFill>
                   <a:srgbClr val="312D2A"/>
                 </a:solidFill>
                 <a:latin typeface="Oracle Sans"/>
               </a:rPr>
-              <a:t>O que a demo mostra</a:t>
+              <a:t>Lab TDC: AI Agents na OCI</a:t>
             </a:r>
           </a:p>
         </p:txBody>
@@ -50476,8 +49911,161 @@
         </p:nvSpPr>
         <p:spPr>
           <a:xfrm>
-            <a:off x="777240" y="1325880"/>
-            <a:ext cx="5577840" cy="3931920"/>
+            <a:off x="521207" y="749808"/>
+            <a:ext cx="4937760" cy="256032"/>
+          </a:xfrm>
+          <a:prstGeom prst="rect">
+            <a:avLst/>
+          </a:prstGeom>
+          <a:noFill/>
+        </p:spPr>
+        <p:txBody>
+          <a:bodyPr wrap="square">
+            <a:spAutoFit/>
+          </a:bodyPr>
+          <a:lstStyle/>
+          <a:p>
+            <a:pPr algn="l"/>
+            <a:r>
+              <a:rPr sz="1400" b="0">
+                <a:solidFill>
+                  <a:srgbClr val="5C5650"/>
+                </a:solidFill>
+                <a:latin typeface="Oracle Sans"/>
+              </a:rPr>
+              <a:t>Arquitetura, QR code e resumo da demo</a:t>
+            </a:r>
+          </a:p>
+        </p:txBody>
+      </p:sp>
+      <p:pic xmlns:a="http://schemas.openxmlformats.org/drawingml/2006/main" xmlns:r="http://schemas.openxmlformats.org/officeDocument/2006/relationships">
+        <p:nvPicPr>
+          <p:cNvPr id="9" name="Picture 8" descr="arquitetura-oci-ai-agents-tdc.png"/>
+          <p:cNvPicPr>
+            <a:picLocks noChangeAspect="1"/>
+          </p:cNvPicPr>
+          <p:nvPr/>
+        </p:nvPicPr>
+        <p:blipFill>
+          <a:blip r:embed="rId3"/>
+          <a:stretch>
+            <a:fillRect/>
+          </a:stretch>
+        </p:blipFill>
+        <p:spPr>
+          <a:xfrm>
+            <a:off x="411480" y="1143000"/>
+            <a:ext cx="7635240" cy="4160520"/>
+          </a:xfrm>
+          <a:prstGeom prst="rect">
+            <a:avLst/>
+          </a:prstGeom>
+        </p:spPr>
+      </p:pic>
+      <p:pic xmlns:a="http://schemas.openxmlformats.org/drawingml/2006/main" xmlns:r="http://schemas.openxmlformats.org/officeDocument/2006/relationships">
+        <p:nvPicPr>
+          <p:cNvPr id="10" name="Picture 9" descr="github-qr.png"/>
+          <p:cNvPicPr>
+            <a:picLocks noChangeAspect="1"/>
+          </p:cNvPicPr>
+          <p:nvPr/>
+        </p:nvPicPr>
+        <p:blipFill>
+          <a:blip r:embed="rId4"/>
+          <a:stretch>
+            <a:fillRect/>
+          </a:stretch>
+        </p:blipFill>
+        <p:spPr>
+          <a:xfrm>
+            <a:off x="9281160" y="658368"/>
+            <a:ext cx="1691640" cy="1691640"/>
+          </a:xfrm>
+          <a:prstGeom prst="rect">
+            <a:avLst/>
+          </a:prstGeom>
+        </p:spPr>
+      </p:pic>
+      <p:sp xmlns:a="http://schemas.openxmlformats.org/drawingml/2006/main">
+        <p:nvSpPr>
+          <p:cNvPr id="11" name="TextBox 10"/>
+          <p:cNvSpPr txBox="1"/>
+          <p:nvPr/>
+        </p:nvSpPr>
+        <p:spPr>
+          <a:xfrm>
+            <a:off x="9144000" y="2395728"/>
+            <a:ext cx="1965960" cy="228600"/>
+          </a:xfrm>
+          <a:prstGeom prst="rect">
+            <a:avLst/>
+          </a:prstGeom>
+          <a:noFill/>
+        </p:spPr>
+        <p:txBody>
+          <a:bodyPr wrap="square">
+            <a:spAutoFit/>
+          </a:bodyPr>
+          <a:lstStyle/>
+          <a:p>
+            <a:pPr algn="ctr"/>
+            <a:r>
+              <a:rPr sz="1300" b="1">
+                <a:solidFill>
+                  <a:srgbClr val="312D2A"/>
+                </a:solidFill>
+                <a:latin typeface="Oracle Sans"/>
+              </a:rPr>
+              <a:t>GitHub do lab</a:t>
+            </a:r>
+          </a:p>
+        </p:txBody>
+      </p:sp>
+      <p:sp xmlns:a="http://schemas.openxmlformats.org/drawingml/2006/main">
+        <p:nvSpPr>
+          <p:cNvPr id="12" name="TextBox 11"/>
+          <p:cNvSpPr txBox="1"/>
+          <p:nvPr/>
+        </p:nvSpPr>
+        <p:spPr>
+          <a:xfrm>
+            <a:off x="8366760" y="2880360"/>
+            <a:ext cx="3200400" cy="320040"/>
+          </a:xfrm>
+          <a:prstGeom prst="rect">
+            <a:avLst/>
+          </a:prstGeom>
+          <a:noFill/>
+        </p:spPr>
+        <p:txBody>
+          <a:bodyPr wrap="square">
+            <a:spAutoFit/>
+          </a:bodyPr>
+          <a:lstStyle/>
+          <a:p>
+            <a:pPr algn="l"/>
+            <a:r>
+              <a:rPr sz="2000" b="1">
+                <a:solidFill>
+                  <a:srgbClr val="312D2A"/>
+                </a:solidFill>
+                <a:latin typeface="Oracle Sans"/>
+              </a:rPr>
+              <a:t>O que a demo ensina</a:t>
+            </a:r>
+          </a:p>
+        </p:txBody>
+      </p:sp>
+      <p:sp xmlns:a="http://schemas.openxmlformats.org/drawingml/2006/main">
+        <p:nvSpPr>
+          <p:cNvPr id="13" name="TextBox 12"/>
+          <p:cNvSpPr txBox="1"/>
+          <p:nvPr/>
+        </p:nvSpPr>
+        <p:spPr>
+          <a:xfrm>
+            <a:off x="8366760" y="3310128"/>
+            <a:ext cx="3154680" cy="1645920"/>
           </a:xfrm>
           <a:prstGeom prst="rect">
             <a:avLst/>
@@ -50494,7 +50082,7 @@
               <a:spcAft>
                 <a:spcPts val="1000"/>
               </a:spcAft>
-              <a:defRPr sz="1900">
+              <a:defRPr sz="1500">
                 <a:solidFill>
                   <a:srgbClr val="312D2A"/>
                 </a:solidFill>
@@ -50502,7 +50090,7 @@
               </a:defRPr>
             </a:pPr>
             <a:r>
-              <a:t>Criacao de um OCI Generative AI Agent em uma tenancy trial do zero.</a:t>
+              <a:t>Agent com RAG: PDF do evento como base de conhecimento.</a:t>
             </a:r>
           </a:p>
           <a:p>
@@ -50510,7 +50098,7 @@
               <a:spcAft>
                 <a:spcPts val="1000"/>
               </a:spcAft>
-              <a:defRPr sz="1900">
+              <a:defRPr sz="1500">
                 <a:solidFill>
                   <a:srgbClr val="312D2A"/>
                 </a:solidFill>
@@ -50518,7 +50106,7 @@
               </a:defRPr>
             </a:pPr>
             <a:r>
-              <a:t>RAG com PDF do TDC Floripa 2026 para contexto geral do evento.</a:t>
+              <a:t>Custom Tool: agenda e speakers via API estruturada.</a:t>
             </a:r>
           </a:p>
           <a:p>
@@ -50526,7 +50114,7 @@
               <a:spcAft>
                 <a:spcPts val="1000"/>
               </a:spcAft>
-              <a:defRPr sz="1900">
+              <a:defRPr sz="1500">
                 <a:solidFill>
                   <a:srgbClr val="312D2A"/>
                 </a:solidFill>
@@ -50534,37 +50122,21 @@
               </a:defRPr>
             </a:pPr>
             <a:r>
-              <a:t>Custom Tool HTTP para buscar agenda, speakers, trilhas e horarios.</a:t>
-            </a:r>
-          </a:p>
-          <a:p>
-            <a:pPr>
-              <a:spcAft>
-                <a:spcPts val="1000"/>
-              </a:spcAft>
-              <a:defRPr sz="1900">
-                <a:solidFill>
-                  <a:srgbClr val="312D2A"/>
-                </a:solidFill>
-                <a:latin typeface="Oracle Sans"/>
-              </a:defRPr>
-            </a:pPr>
-            <a:r>
-              <a:t>Agent Endpoint consumido por um canal externo: Telegram via backend Render.</a:t>
+              <a:t>Endpoint real: consumo pelo Telegram usando backend Render.</a:t>
             </a:r>
           </a:p>
         </p:txBody>
       </p:sp>
       <p:sp xmlns:a="http://schemas.openxmlformats.org/drawingml/2006/main">
         <p:nvSpPr>
-          <p:cNvPr id="9" name="Rounded Rectangle 8"/>
+          <p:cNvPr id="14" name="Rounded Rectangle 13"/>
           <p:cNvSpPr/>
           <p:nvPr/>
         </p:nvSpPr>
         <p:spPr>
           <a:xfrm>
-            <a:off x="6812280" y="1417320"/>
-            <a:ext cx="4206240" cy="502920"/>
+            <a:off x="8458200" y="5230368"/>
+            <a:ext cx="2743200" cy="384048"/>
           </a:xfrm>
           <a:prstGeom prst="roundRect">
             <a:avLst/>
@@ -50574,7 +50146,7 @@
           </a:solidFill>
           <a:ln w="15875">
             <a:solidFill>
-              <a:srgbClr val="759C6C"/>
+              <a:srgbClr val="AE562C"/>
             </a:solidFill>
           </a:ln>
         </p:spPr>
@@ -50598,829 +50170,27 @@
           <a:p>
             <a:pPr algn="ctr"/>
             <a:r>
-              <a:rPr sz="1500" b="1">
+              <a:rPr sz="1300" b="1">
                 <a:solidFill>
                   <a:srgbClr val="312D2A"/>
                 </a:solidFill>
                 <a:latin typeface="Oracle Sans"/>
               </a:rPr>
-              <a:t>RAG = conhecimento nao estruturado</a:t>
+              <a:t>RAG + Tools + Endpoint</a:t>
             </a:r>
           </a:p>
         </p:txBody>
       </p:sp>
       <p:sp xmlns:a="http://schemas.openxmlformats.org/drawingml/2006/main">
         <p:nvSpPr>
-          <p:cNvPr id="10" name="Rounded Rectangle 9"/>
-          <p:cNvSpPr/>
-          <p:nvPr/>
-        </p:nvSpPr>
-        <p:spPr>
-          <a:xfrm>
-            <a:off x="6812280" y="2148840"/>
-            <a:ext cx="4206240" cy="502920"/>
-          </a:xfrm>
-          <a:prstGeom prst="roundRect">
-            <a:avLst/>
-          </a:prstGeom>
-          <a:solidFill>
-            <a:srgbClr val="F5F4F2"/>
-          </a:solidFill>
-          <a:ln w="15875">
-            <a:solidFill>
-              <a:srgbClr val="AE562C"/>
-            </a:solidFill>
-          </a:ln>
-        </p:spPr>
-        <p:style>
-          <a:lnRef idx="1">
-            <a:schemeClr val="accent1"/>
-          </a:lnRef>
-          <a:fillRef idx="3">
-            <a:schemeClr val="accent1"/>
-          </a:fillRef>
-          <a:effectRef idx="2">
-            <a:schemeClr val="accent1"/>
-          </a:effectRef>
-          <a:fontRef idx="minor">
-            <a:schemeClr val="lt1"/>
-          </a:fontRef>
-        </p:style>
-        <p:txBody>
-          <a:bodyPr rtlCol="0" anchor="ctr" lIns="109728" rIns="109728"/>
-          <a:lstStyle/>
-          <a:p>
-            <a:pPr algn="ctr"/>
-            <a:r>
-              <a:rPr sz="1500" b="1">
-                <a:solidFill>
-                  <a:srgbClr val="312D2A"/>
-                </a:solidFill>
-                <a:latin typeface="Oracle Sans"/>
-              </a:rPr>
-              <a:t>Tool = dado estruturado e atualizavel</a:t>
-            </a:r>
-          </a:p>
-        </p:txBody>
-      </p:sp>
-      <p:sp xmlns:a="http://schemas.openxmlformats.org/drawingml/2006/main">
-        <p:nvSpPr>
-          <p:cNvPr id="11" name="Rounded Rectangle 10"/>
-          <p:cNvSpPr/>
-          <p:nvPr/>
-        </p:nvSpPr>
-        <p:spPr>
-          <a:xfrm>
-            <a:off x="6812280" y="2880360"/>
-            <a:ext cx="4206240" cy="502920"/>
-          </a:xfrm>
-          <a:prstGeom prst="roundRect">
-            <a:avLst/>
-          </a:prstGeom>
-          <a:solidFill>
-            <a:srgbClr val="F5F4F2"/>
-          </a:solidFill>
-          <a:ln w="15875">
-            <a:solidFill>
-              <a:srgbClr val="2C5967"/>
-            </a:solidFill>
-          </a:ln>
-        </p:spPr>
-        <p:style>
-          <a:lnRef idx="1">
-            <a:schemeClr val="accent1"/>
-          </a:lnRef>
-          <a:fillRef idx="3">
-            <a:schemeClr val="accent1"/>
-          </a:fillRef>
-          <a:effectRef idx="2">
-            <a:schemeClr val="accent1"/>
-          </a:effectRef>
-          <a:fontRef idx="minor">
-            <a:schemeClr val="lt1"/>
-          </a:fontRef>
-        </p:style>
-        <p:txBody>
-          <a:bodyPr rtlCol="0" anchor="ctr" lIns="109728" rIns="109728"/>
-          <a:lstStyle/>
-          <a:p>
-            <a:pPr algn="ctr"/>
-            <a:r>
-              <a:rPr sz="1500" b="1">
-                <a:solidFill>
-                  <a:srgbClr val="312D2A"/>
-                </a:solidFill>
-                <a:latin typeface="Oracle Sans"/>
-              </a:rPr>
-              <a:t>Endpoint = integracao real</a:t>
-            </a:r>
-          </a:p>
-        </p:txBody>
-      </p:sp>
-      <p:sp xmlns:a="http://schemas.openxmlformats.org/drawingml/2006/main">
-        <p:nvSpPr>
-          <p:cNvPr id="12" name="Rounded Rectangle 11"/>
-          <p:cNvSpPr/>
-          <p:nvPr/>
-        </p:nvSpPr>
-        <p:spPr>
-          <a:xfrm>
-            <a:off x="6812280" y="3611880"/>
-            <a:ext cx="4206240" cy="502920"/>
-          </a:xfrm>
-          <a:prstGeom prst="roundRect">
-            <a:avLst/>
-          </a:prstGeom>
-          <a:solidFill>
-            <a:srgbClr val="F5F4F2"/>
-          </a:solidFill>
-          <a:ln w="15875">
-            <a:solidFill>
-              <a:srgbClr val="A36472"/>
-            </a:solidFill>
-          </a:ln>
-        </p:spPr>
-        <p:style>
-          <a:lnRef idx="1">
-            <a:schemeClr val="accent1"/>
-          </a:lnRef>
-          <a:fillRef idx="3">
-            <a:schemeClr val="accent1"/>
-          </a:fillRef>
-          <a:effectRef idx="2">
-            <a:schemeClr val="accent1"/>
-          </a:effectRef>
-          <a:fontRef idx="minor">
-            <a:schemeClr val="lt1"/>
-          </a:fontRef>
-        </p:style>
-        <p:txBody>
-          <a:bodyPr rtlCol="0" anchor="ctr" lIns="109728" rIns="109728"/>
-          <a:lstStyle/>
-          <a:p>
-            <a:pPr algn="ctr"/>
-            <a:r>
-              <a:rPr sz="1500" b="1">
-                <a:solidFill>
-                  <a:srgbClr val="312D2A"/>
-                </a:solidFill>
-                <a:latin typeface="Oracle Sans"/>
-              </a:rPr>
-              <a:t>Telegram = experiencia de canal</a:t>
-            </a:r>
-          </a:p>
-        </p:txBody>
-      </p:sp>
-    </p:spTree>
-    <p:extLst>
-      <p:ext uri="{BB962C8B-B14F-4D97-AF65-F5344CB8AC3E}">
-        <p14:creationId xmlns:p14="http://schemas.microsoft.com/office/powerpoint/2010/main" val="3409006694"/>
-      </p:ext>
-    </p:extLst>
-  </p:cSld>
-</p:sld>
-</file>
-
-<file path=ppt/slides/slide3.xml><?xml version="1.0" encoding="utf-8"?>
-<p:sld xmlns:p="http://schemas.openxmlformats.org/presentationml/2006/main">
-  <p:cSld>
-    <p:bg>
-      <p:bgPr>
-        <a:solidFill xmlns:a="http://schemas.openxmlformats.org/drawingml/2006/main">
-          <a:schemeClr val="bg2"/>
-        </a:solidFill>
-      </p:bgPr>
-    </p:bg>
-    <p:spTree>
-      <p:nvGrpSpPr>
-        <p:cNvPr id="1" name=""/>
-        <p:cNvGrpSpPr/>
-        <p:nvPr/>
-      </p:nvGrpSpPr>
-      <p:grpSpPr>
-        <a:xfrm xmlns:a="http://schemas.openxmlformats.org/drawingml/2006/main"/>
-      </p:grpSpPr>
-      <p:sp>
-        <p:nvSpPr>
-          <p:cNvPr id="5" name="Slide Number Placeholder 4">
-            <a:extLst xmlns:a="http://schemas.openxmlformats.org/drawingml/2006/main">
-              <a:ext uri="{FF2B5EF4-FFF2-40B4-BE49-F238E27FC236}">
-                <a16:creationId xmlns:a16="http://schemas.microsoft.com/office/drawing/2014/main" id="{D1C1AC08-3D17-B7B4-1AE3-423663671F05}"/>
-              </a:ext>
-            </a:extLst>
-          </p:cNvPr>
-          <p:cNvSpPr>
-            <a:spLocks xmlns:a="http://schemas.openxmlformats.org/drawingml/2006/main" noGrp="1"/>
-          </p:cNvSpPr>
-          <p:nvPr>
-            <p:ph type="sldNum" idx="22"/>
-          </p:nvPr>
-        </p:nvSpPr>
-        <p:spPr>
-          <a:xfrm xmlns:a="http://schemas.openxmlformats.org/drawingml/2006/main">
-            <a:off x="762000" y="6423660"/>
-            <a:ext cx="365760" cy="365760"/>
-          </a:xfrm>
-        </p:spPr>
-        <p:txBody>
-          <a:bodyPr xmlns:a="http://schemas.openxmlformats.org/drawingml/2006/main"/>
-          <a:lstStyle xmlns:a="http://schemas.openxmlformats.org/drawingml/2006/main"/>
-          <a:p xmlns:a="http://schemas.openxmlformats.org/drawingml/2006/main">
-            <a:r>
-              <a:rPr sz="600">
-                <a:solidFill>
-                  <a:srgbClr val="5C5650"/>
-                </a:solidFill>
-                <a:latin typeface="Oracle Sans"/>
-              </a:rPr>
-              <a:t>3</a:t>
-            </a:r>
-          </a:p>
-        </p:txBody>
-      </p:sp>
-      <p:sp>
-        <p:nvSpPr>
-          <p:cNvPr id="6" name="Footer Placeholder 5">
-            <a:extLst xmlns:a="http://schemas.openxmlformats.org/drawingml/2006/main">
-              <a:ext uri="{FF2B5EF4-FFF2-40B4-BE49-F238E27FC236}">
-                <a16:creationId xmlns:a16="http://schemas.microsoft.com/office/drawing/2014/main" id="{0C96F817-67DC-36D5-86CB-CCBE3DAF9CDA}"/>
-              </a:ext>
-            </a:extLst>
-          </p:cNvPr>
-          <p:cNvSpPr>
-            <a:spLocks xmlns:a="http://schemas.openxmlformats.org/drawingml/2006/main" noGrp="1"/>
-          </p:cNvSpPr>
-          <p:nvPr>
-            <p:ph type="ftr" idx="21"/>
-          </p:nvPr>
-        </p:nvSpPr>
-        <p:spPr>
-          <a:xfrm xmlns:a="http://schemas.openxmlformats.org/drawingml/2006/main">
-            <a:off x="1127759" y="6423978"/>
-            <a:ext cx="5745379" cy="365125"/>
-          </a:xfrm>
-        </p:spPr>
-        <p:txBody>
-          <a:bodyPr xmlns:a="http://schemas.openxmlformats.org/drawingml/2006/main"/>
-          <a:lstStyle xmlns:a="http://schemas.openxmlformats.org/drawingml/2006/main"/>
-          <a:p xmlns:a="http://schemas.openxmlformats.org/drawingml/2006/main">
-            <a:r>
-              <a:rPr sz="600">
-                <a:solidFill>
-                  <a:srgbClr val="5C5650"/>
-                </a:solidFill>
-                <a:latin typeface="Oracle Sans"/>
-              </a:rPr>
-              <a:t>Copyright © 2026, Oracle and/or its affiliates | Confidential: Internal</a:t>
-            </a:r>
-          </a:p>
-        </p:txBody>
-      </p:sp>
-      <p:sp xmlns:a="http://schemas.openxmlformats.org/drawingml/2006/main">
-        <p:nvSpPr>
-          <p:cNvPr id="7" name="TextBox 6"/>
+          <p:cNvPr id="15" name="TextBox 14"/>
           <p:cNvSpPr txBox="1"/>
           <p:nvPr/>
         </p:nvSpPr>
         <p:spPr>
           <a:xfrm>
-            <a:off x="640080" y="411480"/>
-            <a:ext cx="6858000" cy="457200"/>
-          </a:xfrm>
-          <a:prstGeom prst="rect">
-            <a:avLst/>
-          </a:prstGeom>
-          <a:noFill/>
-        </p:spPr>
-        <p:txBody>
-          <a:bodyPr wrap="square">
-            <a:spAutoFit/>
-          </a:bodyPr>
-          <a:lstStyle/>
-          <a:p>
-            <a:pPr algn="l"/>
-            <a:r>
-              <a:rPr sz="3000" b="1">
-                <a:solidFill>
-                  <a:srgbClr val="312D2A"/>
-                </a:solidFill>
-                <a:latin typeface="Oracle Sans"/>
-              </a:rPr>
-              <a:t>Arquitetura da solucao</a:t>
-            </a:r>
-          </a:p>
-        </p:txBody>
-      </p:sp>
-      <p:sp xmlns:a="http://schemas.openxmlformats.org/drawingml/2006/main">
-        <p:nvSpPr>
-          <p:cNvPr id="8" name="TextBox 7"/>
-          <p:cNvSpPr txBox="1"/>
-          <p:nvPr/>
-        </p:nvSpPr>
-        <p:spPr>
-          <a:xfrm>
-            <a:off x="658368" y="868680"/>
-            <a:ext cx="7863840" cy="320040"/>
-          </a:xfrm>
-          <a:prstGeom prst="rect">
-            <a:avLst/>
-          </a:prstGeom>
-          <a:noFill/>
-        </p:spPr>
-        <p:txBody>
-          <a:bodyPr wrap="square">
-            <a:spAutoFit/>
-          </a:bodyPr>
-          <a:lstStyle/>
-          <a:p>
-            <a:pPr algn="l"/>
-            <a:r>
-              <a:rPr sz="1500" b="0">
-                <a:solidFill>
-                  <a:srgbClr val="5C5650"/>
-                </a:solidFill>
-                <a:latin typeface="Oracle Sans"/>
-              </a:rPr>
-              <a:t>Do canal externo ao Agent Endpoint, combinando RAG e Custom Tool.</a:t>
-            </a:r>
-          </a:p>
-        </p:txBody>
-      </p:sp>
-      <p:pic xmlns:a="http://schemas.openxmlformats.org/drawingml/2006/main" xmlns:r="http://schemas.openxmlformats.org/officeDocument/2006/relationships">
-        <p:nvPicPr>
-          <p:cNvPr id="9" name="Picture 8" descr="arquitetura-oci-ai-agents-tdc.png"/>
-          <p:cNvPicPr>
-            <a:picLocks noChangeAspect="1"/>
-          </p:cNvPicPr>
-          <p:nvPr/>
-        </p:nvPicPr>
-        <p:blipFill>
-          <a:blip r:embed="rId3"/>
-          <a:stretch>
-            <a:fillRect/>
-          </a:stretch>
-        </p:blipFill>
-        <p:spPr>
-          <a:xfrm>
-            <a:off x="502920" y="1234440"/>
-            <a:ext cx="11201400" cy="4983480"/>
-          </a:xfrm>
-          <a:prstGeom prst="rect">
-            <a:avLst/>
-          </a:prstGeom>
-        </p:spPr>
-      </p:pic>
-    </p:spTree>
-    <p:extLst>
-      <p:ext uri="{BB962C8B-B14F-4D97-AF65-F5344CB8AC3E}">
-        <p14:creationId xmlns:p14="http://schemas.microsoft.com/office/powerpoint/2010/main" val="3409006694"/>
-      </p:ext>
-    </p:extLst>
-  </p:cSld>
-</p:sld>
-</file>
-
-<file path=ppt/slides/slide4.xml><?xml version="1.0" encoding="utf-8"?>
-<p:sld xmlns:p="http://schemas.openxmlformats.org/presentationml/2006/main">
-  <p:cSld>
-    <p:bg>
-      <p:bgPr>
-        <a:solidFill xmlns:a="http://schemas.openxmlformats.org/drawingml/2006/main">
-          <a:schemeClr val="bg2"/>
-        </a:solidFill>
-      </p:bgPr>
-    </p:bg>
-    <p:spTree>
-      <p:nvGrpSpPr>
-        <p:cNvPr id="1" name=""/>
-        <p:cNvGrpSpPr/>
-        <p:nvPr/>
-      </p:nvGrpSpPr>
-      <p:grpSpPr>
-        <a:xfrm xmlns:a="http://schemas.openxmlformats.org/drawingml/2006/main"/>
-      </p:grpSpPr>
-      <p:sp>
-        <p:nvSpPr>
-          <p:cNvPr id="5" name="Slide Number Placeholder 4">
-            <a:extLst xmlns:a="http://schemas.openxmlformats.org/drawingml/2006/main">
-              <a:ext uri="{FF2B5EF4-FFF2-40B4-BE49-F238E27FC236}">
-                <a16:creationId xmlns:a16="http://schemas.microsoft.com/office/drawing/2014/main" id="{D1C1AC08-3D17-B7B4-1AE3-423663671F05}"/>
-              </a:ext>
-            </a:extLst>
-          </p:cNvPr>
-          <p:cNvSpPr>
-            <a:spLocks xmlns:a="http://schemas.openxmlformats.org/drawingml/2006/main" noGrp="1"/>
-          </p:cNvSpPr>
-          <p:nvPr>
-            <p:ph type="sldNum" idx="22"/>
-          </p:nvPr>
-        </p:nvSpPr>
-        <p:spPr>
-          <a:xfrm xmlns:a="http://schemas.openxmlformats.org/drawingml/2006/main">
-            <a:off x="762000" y="6423660"/>
-            <a:ext cx="365760" cy="365760"/>
-          </a:xfrm>
-        </p:spPr>
-        <p:txBody>
-          <a:bodyPr xmlns:a="http://schemas.openxmlformats.org/drawingml/2006/main"/>
-          <a:lstStyle xmlns:a="http://schemas.openxmlformats.org/drawingml/2006/main"/>
-          <a:p xmlns:a="http://schemas.openxmlformats.org/drawingml/2006/main">
-            <a:r>
-              <a:rPr sz="600">
-                <a:solidFill>
-                  <a:srgbClr val="5C5650"/>
-                </a:solidFill>
-                <a:latin typeface="Oracle Sans"/>
-              </a:rPr>
-              <a:t>4</a:t>
-            </a:r>
-          </a:p>
-        </p:txBody>
-      </p:sp>
-      <p:sp>
-        <p:nvSpPr>
-          <p:cNvPr id="6" name="Footer Placeholder 5">
-            <a:extLst xmlns:a="http://schemas.openxmlformats.org/drawingml/2006/main">
-              <a:ext uri="{FF2B5EF4-FFF2-40B4-BE49-F238E27FC236}">
-                <a16:creationId xmlns:a16="http://schemas.microsoft.com/office/drawing/2014/main" id="{0C96F817-67DC-36D5-86CB-CCBE3DAF9CDA}"/>
-              </a:ext>
-            </a:extLst>
-          </p:cNvPr>
-          <p:cNvSpPr>
-            <a:spLocks xmlns:a="http://schemas.openxmlformats.org/drawingml/2006/main" noGrp="1"/>
-          </p:cNvSpPr>
-          <p:nvPr>
-            <p:ph type="ftr" idx="21"/>
-          </p:nvPr>
-        </p:nvSpPr>
-        <p:spPr>
-          <a:xfrm xmlns:a="http://schemas.openxmlformats.org/drawingml/2006/main">
-            <a:off x="1127759" y="6423978"/>
-            <a:ext cx="5745379" cy="365125"/>
-          </a:xfrm>
-        </p:spPr>
-        <p:txBody>
-          <a:bodyPr xmlns:a="http://schemas.openxmlformats.org/drawingml/2006/main"/>
-          <a:lstStyle xmlns:a="http://schemas.openxmlformats.org/drawingml/2006/main"/>
-          <a:p xmlns:a="http://schemas.openxmlformats.org/drawingml/2006/main">
-            <a:r>
-              <a:rPr sz="600">
-                <a:solidFill>
-                  <a:srgbClr val="5C5650"/>
-                </a:solidFill>
-                <a:latin typeface="Oracle Sans"/>
-              </a:rPr>
-              <a:t>Copyright © 2026, Oracle and/or its affiliates | Confidential: Internal</a:t>
-            </a:r>
-          </a:p>
-        </p:txBody>
-      </p:sp>
-      <p:sp xmlns:a="http://schemas.openxmlformats.org/drawingml/2006/main">
-        <p:nvSpPr>
-          <p:cNvPr id="7" name="TextBox 6"/>
-          <p:cNvSpPr txBox="1"/>
-          <p:nvPr/>
-        </p:nvSpPr>
-        <p:spPr>
-          <a:xfrm>
-            <a:off x="640080" y="502920"/>
-            <a:ext cx="6675120" cy="457200"/>
-          </a:xfrm>
-          <a:prstGeom prst="rect">
-            <a:avLst/>
-          </a:prstGeom>
-          <a:noFill/>
-        </p:spPr>
-        <p:txBody>
-          <a:bodyPr wrap="square">
-            <a:spAutoFit/>
-          </a:bodyPr>
-          <a:lstStyle/>
-          <a:p>
-            <a:pPr algn="l"/>
-            <a:r>
-              <a:rPr sz="3000" b="1">
-                <a:solidFill>
-                  <a:srgbClr val="312D2A"/>
-                </a:solidFill>
-                <a:latin typeface="Oracle Sans"/>
-              </a:rPr>
-              <a:t>Roteiro da demonstracao</a:t>
-            </a:r>
-          </a:p>
-        </p:txBody>
-      </p:sp>
-      <p:sp xmlns:a="http://schemas.openxmlformats.org/drawingml/2006/main">
-        <p:nvSpPr>
-          <p:cNvPr id="8" name="TextBox 7"/>
-          <p:cNvSpPr txBox="1"/>
-          <p:nvPr/>
-        </p:nvSpPr>
-        <p:spPr>
-          <a:xfrm>
-            <a:off x="777240" y="1234440"/>
-            <a:ext cx="5852160" cy="4389120"/>
-          </a:xfrm>
-          <a:prstGeom prst="rect">
-            <a:avLst/>
-          </a:prstGeom>
-          <a:noFill/>
-        </p:spPr>
-        <p:txBody>
-          <a:bodyPr wrap="square">
-            <a:spAutoFit/>
-          </a:bodyPr>
-          <a:lstStyle/>
-          <a:p>
-            <a:pPr>
-              <a:spcAft>
-                <a:spcPts val="1000"/>
-              </a:spcAft>
-              <a:defRPr sz="1800">
-                <a:solidFill>
-                  <a:srgbClr val="312D2A"/>
-                </a:solidFill>
-                <a:latin typeface="Oracle Sans"/>
-              </a:defRPr>
-            </a:pPr>
-            <a:r>
-              <a:t>1. Preparar OCI: compartment, policies, bucket, rede e subnet privada.</a:t>
-            </a:r>
-          </a:p>
-          <a:p>
-            <a:pPr>
-              <a:spcAft>
-                <a:spcPts val="1000"/>
-              </a:spcAft>
-              <a:defRPr sz="1800">
-                <a:solidFill>
-                  <a:srgbClr val="312D2A"/>
-                </a:solidFill>
-                <a:latin typeface="Oracle Sans"/>
-              </a:defRPr>
-            </a:pPr>
-            <a:r>
-              <a:t>2. Criar Knowledge Base e ingerir o PDF do evento.</a:t>
-            </a:r>
-          </a:p>
-          <a:p>
-            <a:pPr>
-              <a:spcAft>
-                <a:spcPts val="1000"/>
-              </a:spcAft>
-              <a:defRPr sz="1800">
-                <a:solidFill>
-                  <a:srgbClr val="312D2A"/>
-                </a:solidFill>
-                <a:latin typeface="Oracle Sans"/>
-              </a:defRPr>
-            </a:pPr>
-            <a:r>
-              <a:t>3. Criar Agent, adicionar RAG Tool e Custom Tool via OpenAPI.</a:t>
-            </a:r>
-          </a:p>
-          <a:p>
-            <a:pPr>
-              <a:spcAft>
-                <a:spcPts val="1000"/>
-              </a:spcAft>
-              <a:defRPr sz="1800">
-                <a:solidFill>
-                  <a:srgbClr val="312D2A"/>
-                </a:solidFill>
-                <a:latin typeface="Oracle Sans"/>
-              </a:defRPr>
-            </a:pPr>
-            <a:r>
-              <a:t>4. Testar perguntas: geral do evento, speaker, agenda e roteiro personalizado.</a:t>
-            </a:r>
-          </a:p>
-          <a:p>
-            <a:pPr>
-              <a:spcAft>
-                <a:spcPts val="1000"/>
-              </a:spcAft>
-              <a:defRPr sz="1800">
-                <a:solidFill>
-                  <a:srgbClr val="312D2A"/>
-                </a:solidFill>
-                <a:latin typeface="Oracle Sans"/>
-              </a:defRPr>
-            </a:pPr>
-            <a:r>
-              <a:t>5. Mostrar endpoint em canal externo com Telegram e Render.</a:t>
-            </a:r>
-          </a:p>
-        </p:txBody>
-      </p:sp>
-      <p:sp xmlns:a="http://schemas.openxmlformats.org/drawingml/2006/main">
-        <p:nvSpPr>
-          <p:cNvPr id="9" name="TextBox 8"/>
-          <p:cNvSpPr txBox="1"/>
-          <p:nvPr/>
-        </p:nvSpPr>
-        <p:spPr>
-          <a:xfrm>
-            <a:off x="7086600" y="1234440"/>
-            <a:ext cx="3931920" cy="320040"/>
-          </a:xfrm>
-          <a:prstGeom prst="rect">
-            <a:avLst/>
-          </a:prstGeom>
-          <a:noFill/>
-        </p:spPr>
-        <p:txBody>
-          <a:bodyPr wrap="square">
-            <a:spAutoFit/>
-          </a:bodyPr>
-          <a:lstStyle/>
-          <a:p>
-            <a:pPr algn="l"/>
-            <a:r>
-              <a:rPr sz="1800" b="1">
-                <a:solidFill>
-                  <a:srgbClr val="312D2A"/>
-                </a:solidFill>
-                <a:latin typeface="Oracle Sans"/>
-              </a:rPr>
-              <a:t>Perguntas boas para testar</a:t>
-            </a:r>
-          </a:p>
-        </p:txBody>
-      </p:sp>
-      <p:sp xmlns:a="http://schemas.openxmlformats.org/drawingml/2006/main">
-        <p:nvSpPr>
-          <p:cNvPr id="10" name="TextBox 9"/>
-          <p:cNvSpPr txBox="1"/>
-          <p:nvPr/>
-        </p:nvSpPr>
-        <p:spPr>
-          <a:xfrm>
-            <a:off x="7086600" y="1737360"/>
-            <a:ext cx="3840480" cy="2103120"/>
-          </a:xfrm>
-          <a:prstGeom prst="rect">
-            <a:avLst/>
-          </a:prstGeom>
-          <a:noFill/>
-        </p:spPr>
-        <p:txBody>
-          <a:bodyPr wrap="square">
-            <a:spAutoFit/>
-          </a:bodyPr>
-          <a:lstStyle/>
-          <a:p>
-            <a:pPr>
-              <a:spcAft>
-                <a:spcPts val="1000"/>
-              </a:spcAft>
-              <a:defRPr sz="1600">
-                <a:solidFill>
-                  <a:srgbClr val="5C5650"/>
-                </a:solidFill>
-                <a:latin typeface="Oracle Sans"/>
-              </a:defRPr>
-            </a:pPr>
-            <a:r>
-              <a:t>O que sao as Jornadas TDC?</a:t>
-            </a:r>
-          </a:p>
-          <a:p>
-            <a:pPr>
-              <a:spcAft>
-                <a:spcPts val="1000"/>
-              </a:spcAft>
-              <a:defRPr sz="1600">
-                <a:solidFill>
-                  <a:srgbClr val="5C5650"/>
-                </a:solidFill>
-                <a:latin typeface="Oracle Sans"/>
-              </a:defRPr>
-            </a:pPr>
-            <a:r>
-              <a:t>Quais palestras a Livia Rodrigues vai fazer?</a:t>
-            </a:r>
-          </a:p>
-          <a:p>
-            <a:pPr>
-              <a:spcAft>
-                <a:spcPts val="1000"/>
-              </a:spcAft>
-              <a:defRPr sz="1600">
-                <a:solidFill>
-                  <a:srgbClr val="5C5650"/>
-                </a:solidFill>
-                <a:latin typeface="Oracle Sans"/>
-              </a:defRPr>
-            </a:pPr>
-            <a:r>
-              <a:t>Monte um roteiro para GenAI e arquitetura.</a:t>
-            </a:r>
-          </a:p>
-        </p:txBody>
-      </p:sp>
-    </p:spTree>
-    <p:extLst>
-      <p:ext uri="{BB962C8B-B14F-4D97-AF65-F5344CB8AC3E}">
-        <p14:creationId xmlns:p14="http://schemas.microsoft.com/office/powerpoint/2010/main" val="3409006694"/>
-      </p:ext>
-    </p:extLst>
-  </p:cSld>
-</p:sld>
-</file>
-
-<file path=ppt/slides/slide9.xml><?xml version="1.0" encoding="utf-8"?>
-<p:sld xmlns:p="http://schemas.openxmlformats.org/presentationml/2006/main">
-  <p:cSld>
-    <p:spTree>
-      <p:nvGrpSpPr>
-        <p:cNvPr id="1" name=""/>
-        <p:cNvGrpSpPr/>
-        <p:nvPr/>
-      </p:nvGrpSpPr>
-      <p:grpSpPr>
-        <a:xfrm xmlns:a="http://schemas.openxmlformats.org/drawingml/2006/main"/>
-      </p:grpSpPr>
-      <p:sp xmlns:a="http://schemas.openxmlformats.org/drawingml/2006/main">
-        <p:nvSpPr>
-          <p:cNvPr id="2" name="TextBox 1"/>
-          <p:cNvSpPr txBox="1"/>
-          <p:nvPr/>
-        </p:nvSpPr>
-        <p:spPr>
-          <a:xfrm>
-            <a:off x="685800" y="731520"/>
-            <a:ext cx="6217920" cy="548640"/>
-          </a:xfrm>
-          <a:prstGeom prst="rect">
-            <a:avLst/>
-          </a:prstGeom>
-          <a:noFill/>
-        </p:spPr>
-        <p:txBody>
-          <a:bodyPr wrap="square">
-            <a:spAutoFit/>
-          </a:bodyPr>
-          <a:lstStyle/>
-          <a:p>
-            <a:pPr algn="l"/>
-            <a:r>
-              <a:rPr sz="3200" b="1">
-                <a:solidFill>
-                  <a:srgbClr val="312D2A"/>
-                </a:solidFill>
-                <a:latin typeface="Oracle Sans"/>
-              </a:rPr>
-              <a:t>Material e proximos passos</a:t>
-            </a:r>
-          </a:p>
-        </p:txBody>
-      </p:sp>
-      <p:sp xmlns:a="http://schemas.openxmlformats.org/drawingml/2006/main">
-        <p:nvSpPr>
-          <p:cNvPr id="3" name="TextBox 2"/>
-          <p:cNvSpPr txBox="1"/>
-          <p:nvPr/>
-        </p:nvSpPr>
-        <p:spPr>
-          <a:xfrm>
-            <a:off x="713232" y="1417320"/>
-            <a:ext cx="6675120" cy="914400"/>
-          </a:xfrm>
-          <a:prstGeom prst="rect">
-            <a:avLst/>
-          </a:prstGeom>
-          <a:noFill/>
-        </p:spPr>
-        <p:txBody>
-          <a:bodyPr wrap="square">
-            <a:spAutoFit/>
-          </a:bodyPr>
-          <a:lstStyle/>
-          <a:p>
-            <a:pPr algn="l"/>
-            <a:r>
-              <a:rPr sz="1900" b="0">
-                <a:solidFill>
-                  <a:srgbClr val="312D2A"/>
-                </a:solidFill>
-                <a:latin typeface="Oracle Sans"/>
-              </a:rPr>
-              <a:t>Use o repositorio para repetir o lab, atualizar os assets do TDC e adaptar a tool para outros eventos ou bases internas.</a:t>
-            </a:r>
-          </a:p>
-        </p:txBody>
-      </p:sp>
-      <p:sp xmlns:a="http://schemas.openxmlformats.org/drawingml/2006/main">
-        <p:nvSpPr>
-          <p:cNvPr id="4" name="TextBox 3"/>
-          <p:cNvSpPr txBox="1"/>
-          <p:nvPr/>
-        </p:nvSpPr>
-        <p:spPr>
-          <a:xfrm>
-            <a:off x="713232" y="2834640"/>
-            <a:ext cx="6583680" cy="411480"/>
+            <a:off x="548640" y="6099048"/>
+            <a:ext cx="6766560" cy="256032"/>
           </a:xfrm>
           <a:prstGeom prst="rect">
             <a:avLst/>
@@ -51439,68 +50209,9 @@
                   <a:srgbClr val="2C5967"/>
                 </a:solidFill>
                 <a:latin typeface="Oracle Sans"/>
-                <a:hlinkClick xmlns:ns0="http://schemas.openxmlformats.org/officeDocument/2006/relationships" ns0:id="rId3"/>
+                <a:hlinkClick xmlns:ns0="http://schemas.openxmlformats.org/officeDocument/2006/relationships" ns0:id="rId5"/>
               </a:rPr>
               <a:t>https://github.com/LiviaFernandes/tdc-oci-ai-agents-lab</a:t>
-            </a:r>
-          </a:p>
-        </p:txBody>
-      </p:sp>
-      <p:pic xmlns:a="http://schemas.openxmlformats.org/drawingml/2006/main" xmlns:r="http://schemas.openxmlformats.org/officeDocument/2006/relationships">
-        <p:nvPicPr>
-          <p:cNvPr id="5" name="Picture 4" descr="github-qr.png"/>
-          <p:cNvPicPr>
-            <a:picLocks noChangeAspect="1"/>
-          </p:cNvPicPr>
-          <p:nvPr/>
-        </p:nvPicPr>
-        <p:blipFill>
-          <a:blip r:embed="rId4"/>
-          <a:stretch>
-            <a:fillRect/>
-          </a:stretch>
-        </p:blipFill>
-        <p:spPr>
-          <a:xfrm>
-            <a:off x="8915400" y="1005840"/>
-            <a:ext cx="1965960" cy="1965960"/>
-          </a:xfrm>
-          <a:prstGeom prst="rect">
-            <a:avLst/>
-          </a:prstGeom>
-        </p:spPr>
-      </p:pic>
-      <p:sp xmlns:a="http://schemas.openxmlformats.org/drawingml/2006/main">
-        <p:nvSpPr>
-          <p:cNvPr id="6" name="TextBox 5"/>
-          <p:cNvSpPr txBox="1"/>
-          <p:nvPr/>
-        </p:nvSpPr>
-        <p:spPr>
-          <a:xfrm>
-            <a:off x="8778240" y="3090672"/>
-            <a:ext cx="2286000" cy="320040"/>
-          </a:xfrm>
-          <a:prstGeom prst="rect">
-            <a:avLst/>
-          </a:prstGeom>
-          <a:noFill/>
-        </p:spPr>
-        <p:txBody>
-          <a:bodyPr wrap="square">
-            <a:spAutoFit/>
-          </a:bodyPr>
-          <a:lstStyle/>
-          <a:p>
-            <a:pPr algn="ctr"/>
-            <a:r>
-              <a:rPr sz="1500" b="0">
-                <a:solidFill>
-                  <a:srgbClr val="312D2A"/>
-                </a:solidFill>
-                <a:latin typeface="Oracle Sans"/>
-              </a:rPr>
-              <a:t>GitHub do lab</a:t>
             </a:r>
           </a:p>
         </p:txBody>
@@ -51508,7 +50219,7 @@
     </p:spTree>
     <p:extLst>
       <p:ext uri="{BB962C8B-B14F-4D97-AF65-F5344CB8AC3E}">
-        <p14:creationId xmlns:p14="http://schemas.microsoft.com/office/powerpoint/2010/main" val="2697261938"/>
+        <p14:creationId xmlns:p14="http://schemas.microsoft.com/office/powerpoint/2010/main" val="3409006694"/>
       </p:ext>
     </p:extLst>
   </p:cSld>

</xml_diff>